<commit_message>
Remove client name from the Procure.AI deck
Slide 7 now refers to 'the client' in the three places that named one.
No other slide, image or layout changed.

Co-Authored-By: Claude Opus 5.5 <noreply@anthropic.com>
Claude-Session: https://claude.ai/code/session_012feEEykxnJPDQJzKRiGGVo
</commit_message>
<xml_diff>
--- a/Procure.AI.pptx
+++ b/Procure.AI.pptx
@@ -29361,7 +29361,7 @@
             </a:r>
             <a:r>
               <a:rPr lang="en-US" sz="1400" dirty="0"/>
-              <a:t>or live DAMAC data connection required.</a:t>
+              <a:t>or live client data connection required.</a:t>
             </a:r>
           </a:p>
           <a:p>
@@ -29374,7 +29374,7 @@
             </a:pPr>
             <a:r>
               <a:rPr lang="en-US" sz="1400" dirty="0"/>
-              <a:t>Fully hosted and facilitated by Procure Ai, with dedicated onboarding support and scenario walkthroughs tailored to DAMAC's procurement context.</a:t>
+              <a:t>Fully hosted and facilitated by Procure Ai, with dedicated onboarding support and scenario walkthroughs tailored to the client's procurement context.</a:t>
             </a:r>
           </a:p>
           <a:p>
@@ -29520,7 +29520,7 @@
             </a:pPr>
             <a:r>
               <a:rPr lang="en-US" sz="1400" dirty="0"/>
-              <a:t>PoC hosted on DAMAC environment</a:t>
+              <a:t>PoC hosted on the client environment</a:t>
             </a:r>
           </a:p>
           <a:p>

</xml_diff>